<commit_message>
Remove all references to the fall-detector project — fully isolated project docs
</commit_message>
<xml_diff>
--- a/docs/Autonomous_Survey_Boat_Pitch.pptx
+++ b/docs/Autonomous_Survey_Boat_Pitch.pptx
@@ -3308,7 +3308,7 @@
             <a:pPr/>
             <a:r>
               <a:rPr sz="2100"/>
-              <a:t>Set up the repo, project board, and interface contracts — same structure as the fall-detector project</a:t>
+              <a:t>Set up the repo, project board, and interface contracts for the 5 sub-teams</a:t>
             </a:r>
           </a:p>
           <a:p>
@@ -3904,7 +3904,7 @@
             <a:pPr/>
             <a:r>
               <a:rPr sz="1800" i="1"/>
-              <a:t>Same governance model as our fall-detector project: interface contracts between teams, weekly sync, bi-weekly demo</a:t>
+              <a:t>Interface contracts between teams, weekly sync, bi-weekly demo keep 5 sub-teams working in parallel</a:t>
             </a:r>
           </a:p>
         </p:txBody>

</xml_diff>